<commit_message>
chore: update newsletter with live data - 2026-05-23
</commit_message>
<xml_diff>
--- a/newsletter_20260523.pptx
+++ b/newsletter_20260523.pptx
@@ -3908,7 +3908,7 @@
             <a:avLst/>
           </a:prstGeom>
           <a:solidFill>
-            <a:srgbClr val="2E7D32"/>
+            <a:srgbClr val="E65C00"/>
           </a:solidFill>
           <a:ln>
             <a:noFill/>
@@ -3965,7 +3965,7 @@
                   <a:srgbClr val="FFFFFF"/>
                 </a:solidFill>
               </a:rPr>
-              <a:t>5</a:t>
+              <a:t>7</a:t>
             </a:r>
           </a:p>
         </p:txBody>
@@ -4033,7 +4033,7 @@
                   <a:srgbClr val="212121"/>
                 </a:solidFill>
               </a:rPr>
-              <a:t>Viajó de La Alhambra hasta esta ciudad hondureña y hoy es considerado el reloj más antiguo de t…</a:t>
+              <a:t>En la era de los drones y los misiles inteligentes, EEUU ha recuperado una reliquia de la Prime…</a:t>
             </a:r>
           </a:p>
         </p:txBody>
@@ -4096,7 +4096,7 @@
             <a:avLst/>
           </a:prstGeom>
           <a:solidFill>
-            <a:srgbClr val="2E7D32"/>
+            <a:srgbClr val="E65C00"/>
           </a:solidFill>
           <a:ln>
             <a:noFill/>
@@ -4153,7 +4153,7 @@
                   <a:srgbClr val="FFFFFF"/>
                 </a:solidFill>
               </a:rPr>
-              <a:t>5</a:t>
+              <a:t>7</a:t>
             </a:r>
           </a:p>
         </p:txBody>
@@ -4187,7 +4187,7 @@
                   <a:srgbClr val="1A237E"/>
                 </a:solidFill>
               </a:rPr>
-              <a:t>Geopolítica</a:t>
+              <a:t>Cooperativismo</a:t>
             </a:r>
           </a:p>
         </p:txBody>
@@ -4221,7 +4221,7 @@
                   <a:srgbClr val="212121"/>
                 </a:solidFill>
               </a:rPr>
-              <a:t>Rubio comenta las negociaciones con Irán</a:t>
+              <a:t>El Correo Ilustrado</a:t>
             </a:r>
           </a:p>
         </p:txBody>
@@ -4409,7 +4409,7 @@
                   <a:srgbClr val="212121"/>
                 </a:solidFill>
               </a:rPr>
-              <a:t>El Señor de los Anillos celebra su 25 aniversario en cines con una exclusiva colección de moned…</a:t>
+              <a:t>Pedro Sánchez acelera el gran rearme naval de España: el portaaviones que cambiará la Armada pa…</a:t>
             </a:r>
           </a:p>
         </p:txBody>
@@ -4597,7 +4597,7 @@
                   <a:srgbClr val="212121"/>
                 </a:solidFill>
               </a:rPr>
-              <a:t>Cuatro de los españoles de la flotilla detenidos por Israel han necesitado atención médica, seg…</a:t>
+              <a:t>Helldivers 2 prepara su mayor cambio… y podría salvar el juego</a:t>
             </a:r>
           </a:p>
         </p:txBody>
@@ -4751,7 +4751,7 @@
                   <a:srgbClr val="1A237E"/>
                 </a:solidFill>
               </a:rPr>
-              <a:t>Cooperativismo</a:t>
+              <a:t>Geopolítica</a:t>
             </a:r>
           </a:p>
         </p:txBody>
@@ -4785,7 +4785,7 @@
                   <a:srgbClr val="212121"/>
                 </a:solidFill>
               </a:rPr>
-              <a:t>Roban la cartera a un hombre de 93 años que acababa de darle una limosna a sus ladrones en Sevi…</a:t>
+              <a:t>El Gobierno informó el logro de una cosecha récord de 163,2 millones de toneladas de granos</a:t>
             </a:r>
           </a:p>
         </p:txBody>
@@ -4973,7 +4973,7 @@
                   <a:srgbClr val="212121"/>
                 </a:solidFill>
               </a:rPr>
-              <a:t>La Plataforma Bienvenidos refugiados de La Rioja realiza una recogida de ropa y enseres para mi…</a:t>
+              <a:t>Qué hacer este fin de semana en el área de Ferrol: el verano calienta motores con festivales y …</a:t>
             </a:r>
           </a:p>
         </p:txBody>
@@ -5161,7 +5161,7 @@
                   <a:srgbClr val="212121"/>
                 </a:solidFill>
               </a:rPr>
-              <a:t>Detenida en Sevilla por asaltar y robar la cartera de un hombre de más de 90 años tras pedirle …</a:t>
+              <a:t>El Sindicato de Inquilinas se encierra en la sede de la Seguridad Social hasta que el Gobierno …</a:t>
             </a:r>
           </a:p>
         </p:txBody>
@@ -5349,7 +5349,7 @@
                   <a:srgbClr val="212121"/>
                 </a:solidFill>
               </a:rPr>
-              <a:t>Alumnos de Murcia celebran el Día de la Diversidad Cultural con una conexión en directo con la …</a:t>
+              <a:t>BeOne Medicines lanza una campaña global de concienciación sobre el cáncer junto al exportero T…</a:t>
             </a:r>
           </a:p>
         </p:txBody>
@@ -5649,7 +5649,7 @@
                   <a:srgbClr val="212121"/>
                 </a:solidFill>
               </a:rPr>
-              <a:t>Viajó de La Alhambra hasta esta ciudad hondureña y hoy es considerado el reloj más antiguo…</a:t>
+              <a:t>El Gobierno informó el logro de una cosecha récord de 163,2 millones de toneladas de grano…</a:t>
             </a:r>
           </a:p>
         </p:txBody>
@@ -5683,7 +5683,7 @@
                   <a:srgbClr val="757575"/>
                 </a:solidFill>
               </a:rPr>
-              <a:t>La catedral de Comayagua, considerada una de las obras arquitectónicas más bellas del país, alberga una joya que ha superado terremotos y el paso de los siglos_x000D_…</a:t>
+              <a:t>Luego de la baja de las retenciones anunciada ayer por el presidente Javier Milei, la Secretaría de Agricultura señaló que la producción 2025/2026 del campo reg…</a:t>
             </a:r>
           </a:p>
         </p:txBody>
@@ -5717,7 +5717,7 @@
                   <a:srgbClr val="757575"/>
                 </a:solidFill>
               </a:rPr>
-              <a:t>📰 Eldiario.es</a:t>
+              <a:t>📰 La Nacion</a:t>
             </a:r>
           </a:p>
         </p:txBody>
@@ -5914,7 +5914,7 @@
                   <a:srgbClr val="212121"/>
                 </a:solidFill>
               </a:rPr>
-              <a:t>Cuatro de los españoles de la flotilla detenidos por Israel han necesitado atención médica…</a:t>
+              <a:t>Pedro Sánchez acelera el gran rearme naval de España: el portaaviones que cambiará la Arma…</a:t>
             </a:r>
           </a:p>
         </p:txBody>
@@ -5948,7 +5948,7 @@
                   <a:srgbClr val="757575"/>
                 </a:solidFill>
               </a:rPr>
-              <a:t>Cuatro de los alrededor de 40 españoles que viajaban a bordo de la flotilla a Gaza interceptada por Israel y que fueron expulsados la víspera hacia Turquía han …</a:t>
+              <a:t>Pedro Sánchez mantiene un discurso político centrado en la diplomacia y la estabilidad internacional, pero España ya trabaja en uno de los mayores proyectos mil…</a:t>
             </a:r>
           </a:p>
         </p:txBody>
@@ -5982,7 +5982,7 @@
                   <a:srgbClr val="757575"/>
                 </a:solidFill>
               </a:rPr>
-              <a:t>📰 Europapress.es</a:t>
+              <a:t>📰 Elconfidencialdigital.com</a:t>
             </a:r>
           </a:p>
         </p:txBody>
@@ -6045,7 +6045,7 @@
             <a:avLst/>
           </a:prstGeom>
           <a:solidFill>
-            <a:srgbClr val="2E7D32"/>
+            <a:srgbClr val="E65C00"/>
           </a:solidFill>
           <a:ln>
             <a:noFill/>
@@ -6083,6 +6083,228 @@
           <a:xfrm>
             <a:off x="8138160" y="3785616"/>
             <a:ext cx="640080" cy="274320"/>
+          </a:xfrm>
+          <a:prstGeom prst="rect">
+            <a:avLst/>
+          </a:prstGeom>
+          <a:solidFill>
+            <a:srgbClr val="E65C00"/>
+          </a:solidFill>
+          <a:ln>
+            <a:noFill/>
+          </a:ln>
+        </p:spPr>
+        <p:style>
+          <a:lnRef idx="1">
+            <a:schemeClr val="accent1"/>
+          </a:lnRef>
+          <a:fillRef idx="3">
+            <a:schemeClr val="accent1"/>
+          </a:fillRef>
+          <a:effectRef idx="2">
+            <a:schemeClr val="accent1"/>
+          </a:effectRef>
+          <a:fontRef idx="minor">
+            <a:schemeClr val="lt1"/>
+          </a:fontRef>
+        </p:style>
+        <p:txBody>
+          <a:bodyPr rtlCol="0" anchor="ctr"/>
+          <a:lstStyle/>
+          <a:p>
+            <a:pPr algn="ctr"/>
+          </a:p>
+        </p:txBody>
+      </p:sp>
+      <p:sp>
+        <p:nvSpPr>
+          <p:cNvPr id="21" name="TextBox 20"/>
+          <p:cNvSpPr txBox="1"/>
+          <p:nvPr/>
+        </p:nvSpPr>
+        <p:spPr>
+          <a:xfrm>
+            <a:off x="8138160" y="3785616"/>
+            <a:ext cx="640080" cy="274320"/>
+          </a:xfrm>
+          <a:prstGeom prst="rect">
+            <a:avLst/>
+          </a:prstGeom>
+          <a:noFill/>
+        </p:spPr>
+        <p:txBody>
+          <a:bodyPr wrap="square">
+            <a:spAutoFit/>
+          </a:bodyPr>
+          <a:lstStyle/>
+          <a:p>
+            <a:pPr algn="ctr"/>
+            <a:r>
+              <a:rPr sz="900" b="1">
+                <a:solidFill>
+                  <a:srgbClr val="FFFFFF"/>
+                </a:solidFill>
+              </a:rPr>
+              <a:t>7/10</a:t>
+            </a:r>
+          </a:p>
+        </p:txBody>
+      </p:sp>
+      <p:sp>
+        <p:nvSpPr>
+          <p:cNvPr id="22" name="TextBox 21"/>
+          <p:cNvSpPr txBox="1"/>
+          <p:nvPr/>
+        </p:nvSpPr>
+        <p:spPr>
+          <a:xfrm>
+            <a:off x="457200" y="3785616"/>
+            <a:ext cx="7498080" cy="347472"/>
+          </a:xfrm>
+          <a:prstGeom prst="rect">
+            <a:avLst/>
+          </a:prstGeom>
+          <a:noFill/>
+        </p:spPr>
+        <p:txBody>
+          <a:bodyPr wrap="square">
+            <a:spAutoFit/>
+          </a:bodyPr>
+          <a:lstStyle/>
+          <a:p>
+            <a:pPr algn="l"/>
+            <a:r>
+              <a:rPr sz="1100" b="1">
+                <a:solidFill>
+                  <a:srgbClr val="212121"/>
+                </a:solidFill>
+              </a:rPr>
+              <a:t>En la era de los drones y los misiles inteligentes, EEUU ha recuperado una reliquia de la …</a:t>
+            </a:r>
+          </a:p>
+        </p:txBody>
+      </p:sp>
+      <p:sp>
+        <p:nvSpPr>
+          <p:cNvPr id="23" name="TextBox 22"/>
+          <p:cNvSpPr txBox="1"/>
+          <p:nvPr/>
+        </p:nvSpPr>
+        <p:spPr>
+          <a:xfrm>
+            <a:off x="457200" y="4133088"/>
+            <a:ext cx="8321040" cy="502920"/>
+          </a:xfrm>
+          <a:prstGeom prst="rect">
+            <a:avLst/>
+          </a:prstGeom>
+          <a:noFill/>
+        </p:spPr>
+        <p:txBody>
+          <a:bodyPr wrap="square">
+            <a:spAutoFit/>
+          </a:bodyPr>
+          <a:lstStyle/>
+          <a:p>
+            <a:pPr algn="l"/>
+            <a:r>
+              <a:rPr sz="900" b="0">
+                <a:solidFill>
+                  <a:srgbClr val="757575"/>
+                </a:solidFill>
+              </a:rPr>
+              <a:t>En plena guerra de Irak, un grupo de soldados británicos lanzó una carga a la bayoneta contra milicianos iraquíes cerca de Al Amara. La escena parecía salida de…</a:t>
+            </a:r>
+          </a:p>
+        </p:txBody>
+      </p:sp>
+      <p:sp>
+        <p:nvSpPr>
+          <p:cNvPr id="24" name="TextBox 23"/>
+          <p:cNvSpPr txBox="1"/>
+          <p:nvPr/>
+        </p:nvSpPr>
+        <p:spPr>
+          <a:xfrm>
+            <a:off x="457200" y="4654296"/>
+            <a:ext cx="3657600" cy="228600"/>
+          </a:xfrm>
+          <a:prstGeom prst="rect">
+            <a:avLst/>
+          </a:prstGeom>
+          <a:noFill/>
+        </p:spPr>
+        <p:txBody>
+          <a:bodyPr wrap="square">
+            <a:spAutoFit/>
+          </a:bodyPr>
+          <a:lstStyle/>
+          <a:p>
+            <a:pPr algn="l"/>
+            <a:r>
+              <a:rPr sz="800" b="0">
+                <a:solidFill>
+                  <a:srgbClr val="757575"/>
+                </a:solidFill>
+              </a:rPr>
+              <a:t>📰 Xataka.com</a:t>
+            </a:r>
+          </a:p>
+        </p:txBody>
+      </p:sp>
+      <p:sp>
+        <p:nvSpPr>
+          <p:cNvPr id="25" name="Rectangle 24"/>
+          <p:cNvSpPr/>
+          <p:nvPr/>
+        </p:nvSpPr>
+        <p:spPr>
+          <a:xfrm>
+            <a:off x="274320" y="5038344"/>
+            <a:ext cx="8595360" cy="1234440"/>
+          </a:xfrm>
+          <a:prstGeom prst="rect">
+            <a:avLst/>
+          </a:prstGeom>
+          <a:solidFill>
+            <a:srgbClr val="FFFFFF"/>
+          </a:solidFill>
+          <a:ln>
+            <a:noFill/>
+          </a:ln>
+        </p:spPr>
+        <p:style>
+          <a:lnRef idx="1">
+            <a:schemeClr val="accent1"/>
+          </a:lnRef>
+          <a:fillRef idx="3">
+            <a:schemeClr val="accent1"/>
+          </a:fillRef>
+          <a:effectRef idx="2">
+            <a:schemeClr val="accent1"/>
+          </a:effectRef>
+          <a:fontRef idx="minor">
+            <a:schemeClr val="lt1"/>
+          </a:fontRef>
+        </p:style>
+        <p:txBody>
+          <a:bodyPr rtlCol="0" anchor="ctr"/>
+          <a:lstStyle/>
+          <a:p>
+            <a:pPr algn="ctr"/>
+          </a:p>
+        </p:txBody>
+      </p:sp>
+      <p:sp>
+        <p:nvSpPr>
+          <p:cNvPr id="26" name="Rectangle 25"/>
+          <p:cNvSpPr/>
+          <p:nvPr/>
+        </p:nvSpPr>
+        <p:spPr>
+          <a:xfrm>
+            <a:off x="274320" y="5038344"/>
+            <a:ext cx="54864" cy="1234440"/>
           </a:xfrm>
           <a:prstGeom prst="rect">
             <a:avLst/>
@@ -6118,193 +6340,14 @@
       </p:sp>
       <p:sp>
         <p:nvSpPr>
-          <p:cNvPr id="21" name="TextBox 20"/>
-          <p:cNvSpPr txBox="1"/>
-          <p:nvPr/>
-        </p:nvSpPr>
-        <p:spPr>
-          <a:xfrm>
-            <a:off x="8138160" y="3785616"/>
+          <p:cNvPr id="27" name="Rectangle 26"/>
+          <p:cNvSpPr/>
+          <p:nvPr/>
+        </p:nvSpPr>
+        <p:spPr>
+          <a:xfrm>
+            <a:off x="8138160" y="5129784"/>
             <a:ext cx="640080" cy="274320"/>
-          </a:xfrm>
-          <a:prstGeom prst="rect">
-            <a:avLst/>
-          </a:prstGeom>
-          <a:noFill/>
-        </p:spPr>
-        <p:txBody>
-          <a:bodyPr wrap="square">
-            <a:spAutoFit/>
-          </a:bodyPr>
-          <a:lstStyle/>
-          <a:p>
-            <a:pPr algn="ctr"/>
-            <a:r>
-              <a:rPr sz="900" b="1">
-                <a:solidFill>
-                  <a:srgbClr val="FFFFFF"/>
-                </a:solidFill>
-              </a:rPr>
-              <a:t>5/10</a:t>
-            </a:r>
-          </a:p>
-        </p:txBody>
-      </p:sp>
-      <p:sp>
-        <p:nvSpPr>
-          <p:cNvPr id="22" name="TextBox 21"/>
-          <p:cNvSpPr txBox="1"/>
-          <p:nvPr/>
-        </p:nvSpPr>
-        <p:spPr>
-          <a:xfrm>
-            <a:off x="457200" y="3785616"/>
-            <a:ext cx="7498080" cy="347472"/>
-          </a:xfrm>
-          <a:prstGeom prst="rect">
-            <a:avLst/>
-          </a:prstGeom>
-          <a:noFill/>
-        </p:spPr>
-        <p:txBody>
-          <a:bodyPr wrap="square">
-            <a:spAutoFit/>
-          </a:bodyPr>
-          <a:lstStyle/>
-          <a:p>
-            <a:pPr algn="l"/>
-            <a:r>
-              <a:rPr sz="1100" b="1">
-                <a:solidFill>
-                  <a:srgbClr val="212121"/>
-                </a:solidFill>
-              </a:rPr>
-              <a:t>El Señor de los Anillos celebra su 25 aniversario en cines con una exclusiva colección de …</a:t>
-            </a:r>
-          </a:p>
-        </p:txBody>
-      </p:sp>
-      <p:sp>
-        <p:nvSpPr>
-          <p:cNvPr id="23" name="TextBox 22"/>
-          <p:cNvSpPr txBox="1"/>
-          <p:nvPr/>
-        </p:nvSpPr>
-        <p:spPr>
-          <a:xfrm>
-            <a:off x="457200" y="4133088"/>
-            <a:ext cx="8321040" cy="502920"/>
-          </a:xfrm>
-          <a:prstGeom prst="rect">
-            <a:avLst/>
-          </a:prstGeom>
-          <a:noFill/>
-        </p:spPr>
-        <p:txBody>
-          <a:bodyPr wrap="square">
-            <a:spAutoFit/>
-          </a:bodyPr>
-          <a:lstStyle/>
-          <a:p>
-            <a:pPr algn="l"/>
-            <a:r>
-              <a:rPr sz="900" b="0">
-                <a:solidFill>
-                  <a:srgbClr val="757575"/>
-                </a:solidFill>
-              </a:rPr>
-              <a:t>Buenas noticias para los fans de la Tierra Media. La Casa de la Moneda del Reino Unido (The Royal Mint) ha lanzado una exclusiva colección de monedas para conme…</a:t>
-            </a:r>
-          </a:p>
-        </p:txBody>
-      </p:sp>
-      <p:sp>
-        <p:nvSpPr>
-          <p:cNvPr id="24" name="TextBox 23"/>
-          <p:cNvSpPr txBox="1"/>
-          <p:nvPr/>
-        </p:nvSpPr>
-        <p:spPr>
-          <a:xfrm>
-            <a:off x="457200" y="4654296"/>
-            <a:ext cx="3657600" cy="228600"/>
-          </a:xfrm>
-          <a:prstGeom prst="rect">
-            <a:avLst/>
-          </a:prstGeom>
-          <a:noFill/>
-        </p:spPr>
-        <p:txBody>
-          <a:bodyPr wrap="square">
-            <a:spAutoFit/>
-          </a:bodyPr>
-          <a:lstStyle/>
-          <a:p>
-            <a:pPr algn="l"/>
-            <a:r>
-              <a:rPr sz="800" b="0">
-                <a:solidFill>
-                  <a:srgbClr val="757575"/>
-                </a:solidFill>
-              </a:rPr>
-              <a:t>📰 Culturaocio.com</a:t>
-            </a:r>
-          </a:p>
-        </p:txBody>
-      </p:sp>
-      <p:sp>
-        <p:nvSpPr>
-          <p:cNvPr id="25" name="Rectangle 24"/>
-          <p:cNvSpPr/>
-          <p:nvPr/>
-        </p:nvSpPr>
-        <p:spPr>
-          <a:xfrm>
-            <a:off x="274320" y="5038344"/>
-            <a:ext cx="8595360" cy="1234440"/>
-          </a:xfrm>
-          <a:prstGeom prst="rect">
-            <a:avLst/>
-          </a:prstGeom>
-          <a:solidFill>
-            <a:srgbClr val="FFFFFF"/>
-          </a:solidFill>
-          <a:ln>
-            <a:noFill/>
-          </a:ln>
-        </p:spPr>
-        <p:style>
-          <a:lnRef idx="1">
-            <a:schemeClr val="accent1"/>
-          </a:lnRef>
-          <a:fillRef idx="3">
-            <a:schemeClr val="accent1"/>
-          </a:fillRef>
-          <a:effectRef idx="2">
-            <a:schemeClr val="accent1"/>
-          </a:effectRef>
-          <a:fontRef idx="minor">
-            <a:schemeClr val="lt1"/>
-          </a:fontRef>
-        </p:style>
-        <p:txBody>
-          <a:bodyPr rtlCol="0" anchor="ctr"/>
-          <a:lstStyle/>
-          <a:p>
-            <a:pPr algn="ctr"/>
-          </a:p>
-        </p:txBody>
-      </p:sp>
-      <p:sp>
-        <p:nvSpPr>
-          <p:cNvPr id="26" name="Rectangle 25"/>
-          <p:cNvSpPr/>
-          <p:nvPr/>
-        </p:nvSpPr>
-        <p:spPr>
-          <a:xfrm>
-            <a:off x="274320" y="5038344"/>
-            <a:ext cx="54864" cy="1234440"/>
           </a:xfrm>
           <a:prstGeom prst="rect">
             <a:avLst/>
@@ -6340,49 +6383,6 @@
       </p:sp>
       <p:sp>
         <p:nvSpPr>
-          <p:cNvPr id="27" name="Rectangle 26"/>
-          <p:cNvSpPr/>
-          <p:nvPr/>
-        </p:nvSpPr>
-        <p:spPr>
-          <a:xfrm>
-            <a:off x="8138160" y="5129784"/>
-            <a:ext cx="640080" cy="274320"/>
-          </a:xfrm>
-          <a:prstGeom prst="rect">
-            <a:avLst/>
-          </a:prstGeom>
-          <a:solidFill>
-            <a:srgbClr val="2E7D32"/>
-          </a:solidFill>
-          <a:ln>
-            <a:noFill/>
-          </a:ln>
-        </p:spPr>
-        <p:style>
-          <a:lnRef idx="1">
-            <a:schemeClr val="accent1"/>
-          </a:lnRef>
-          <a:fillRef idx="3">
-            <a:schemeClr val="accent1"/>
-          </a:fillRef>
-          <a:effectRef idx="2">
-            <a:schemeClr val="accent1"/>
-          </a:effectRef>
-          <a:fontRef idx="minor">
-            <a:schemeClr val="lt1"/>
-          </a:fontRef>
-        </p:style>
-        <p:txBody>
-          <a:bodyPr rtlCol="0" anchor="ctr"/>
-          <a:lstStyle/>
-          <a:p>
-            <a:pPr algn="ctr"/>
-          </a:p>
-        </p:txBody>
-      </p:sp>
-      <p:sp>
-        <p:nvSpPr>
           <p:cNvPr id="28" name="TextBox 27"/>
           <p:cNvSpPr txBox="1"/>
           <p:nvPr/>
@@ -6444,7 +6444,7 @@
                   <a:srgbClr val="212121"/>
                 </a:solidFill>
               </a:rPr>
-              <a:t>Rubio comenta las negociaciones con Irán</a:t>
+              <a:t>Helldivers 2 prepara su mayor cambio… y podría salvar el juego</a:t>
             </a:r>
           </a:p>
         </p:txBody>
@@ -6478,7 +6478,7 @@
                   <a:srgbClr val="757575"/>
                 </a:solidFill>
               </a:rPr>
-              <a:t>El secretario de Estado de Estados Unidos, Marco Rubio, anunció este viernes desde Suecia que ha habido "algún ligero avance" en las negociaciones con Irán, e i…</a:t>
+              <a:t>Helldivers 2 apunta a reinventarse. Como suele destacar Kotaku, los juegos como servicio no mueren por falta de contenido… sino por problemas técnicos.</a:t>
             </a:r>
           </a:p>
         </p:txBody>
@@ -6512,7 +6512,7 @@
                   <a:srgbClr val="757575"/>
                 </a:solidFill>
               </a:rPr>
-              <a:t>📰 RT</a:t>
+              <a:t>📰 Gizmodo.com</a:t>
             </a:r>
           </a:p>
         </p:txBody>
@@ -7086,7 +7086,7 @@
                   <a:srgbClr val="212121"/>
                 </a:solidFill>
               </a:rPr>
-              <a:t>Roban la cartera a un hombre de 93 años que acababa de darle una limosna a sus ladrones en…</a:t>
+              <a:t>Qué hacer este fin de semana en el área de Ferrol: el verano calienta motores con festival…</a:t>
             </a:r>
           </a:p>
         </p:txBody>
@@ -7120,7 +7120,7 @@
                   <a:srgbClr val="757575"/>
                 </a:solidFill>
               </a:rPr>
-              <a:t>La Guardia Civil ha detenido a una mujer e investiga a otro hombre por el presunto robo de la cartera de un hombre de 93 años que accedió a dar limosna a la pri…</a:t>
+              <a:t>Las comarcas de Ferrolterra, Eume y Ortegal sortearán el calor de este fin de semana con un buen puñado de fiestas patronales como las de Perlío, conciertos com…</a:t>
             </a:r>
           </a:p>
         </p:txBody>
@@ -7154,7 +7154,7 @@
                   <a:srgbClr val="757575"/>
                 </a:solidFill>
               </a:rPr>
-              <a:t>📰 Www.abc.es</a:t>
+              <a:t>📰 Lavozdegalicia.es</a:t>
             </a:r>
           </a:p>
         </p:txBody>
@@ -7351,7 +7351,7 @@
                   <a:srgbClr val="212121"/>
                 </a:solidFill>
               </a:rPr>
-              <a:t>Detenida en Sevilla por asaltar y robar la cartera de un hombre de más de 90 años tras ped…</a:t>
+              <a:t>BeOne Medicines lanza una campaña global de concienciación sobre el cáncer junto al export…</a:t>
             </a:r>
           </a:p>
         </p:txBody>
@@ -7385,7 +7385,7 @@
                   <a:srgbClr val="757575"/>
                 </a:solidFill>
               </a:rPr>
-              <a:t>La Guardia Civil ha detenido a una mujer e investiga a otro hombre por presuntamente haber robado la cartera de un hombre de 93 años que accedió a dar limosna a…</a:t>
+              <a:t>La multinacional donará 300.000 dólares para crear campos de juego cerca de hospitales oncológicos en Europa, Asia y Estados Unidos.</a:t>
             </a:r>
           </a:p>
         </p:txBody>
@@ -7419,7 +7419,7 @@
                   <a:srgbClr val="757575"/>
                 </a:solidFill>
               </a:rPr>
-              <a:t>📰 Europapress.es</a:t>
+              <a:t>📰 Libertaddigital.com</a:t>
             </a:r>
           </a:p>
         </p:txBody>
@@ -7482,7 +7482,7 @@
             <a:avLst/>
           </a:prstGeom>
           <a:solidFill>
-            <a:srgbClr val="2E7D32"/>
+            <a:srgbClr val="E65C00"/>
           </a:solidFill>
           <a:ln>
             <a:noFill/>
@@ -7520,6 +7520,228 @@
           <a:xfrm>
             <a:off x="8138160" y="3785616"/>
             <a:ext cx="640080" cy="274320"/>
+          </a:xfrm>
+          <a:prstGeom prst="rect">
+            <a:avLst/>
+          </a:prstGeom>
+          <a:solidFill>
+            <a:srgbClr val="E65C00"/>
+          </a:solidFill>
+          <a:ln>
+            <a:noFill/>
+          </a:ln>
+        </p:spPr>
+        <p:style>
+          <a:lnRef idx="1">
+            <a:schemeClr val="accent1"/>
+          </a:lnRef>
+          <a:fillRef idx="3">
+            <a:schemeClr val="accent1"/>
+          </a:fillRef>
+          <a:effectRef idx="2">
+            <a:schemeClr val="accent1"/>
+          </a:effectRef>
+          <a:fontRef idx="minor">
+            <a:schemeClr val="lt1"/>
+          </a:fontRef>
+        </p:style>
+        <p:txBody>
+          <a:bodyPr rtlCol="0" anchor="ctr"/>
+          <a:lstStyle/>
+          <a:p>
+            <a:pPr algn="ctr"/>
+          </a:p>
+        </p:txBody>
+      </p:sp>
+      <p:sp>
+        <p:nvSpPr>
+          <p:cNvPr id="21" name="TextBox 20"/>
+          <p:cNvSpPr txBox="1"/>
+          <p:nvPr/>
+        </p:nvSpPr>
+        <p:spPr>
+          <a:xfrm>
+            <a:off x="8138160" y="3785616"/>
+            <a:ext cx="640080" cy="274320"/>
+          </a:xfrm>
+          <a:prstGeom prst="rect">
+            <a:avLst/>
+          </a:prstGeom>
+          <a:noFill/>
+        </p:spPr>
+        <p:txBody>
+          <a:bodyPr wrap="square">
+            <a:spAutoFit/>
+          </a:bodyPr>
+          <a:lstStyle/>
+          <a:p>
+            <a:pPr algn="ctr"/>
+            <a:r>
+              <a:rPr sz="900" b="1">
+                <a:solidFill>
+                  <a:srgbClr val="FFFFFF"/>
+                </a:solidFill>
+              </a:rPr>
+              <a:t>7/10</a:t>
+            </a:r>
+          </a:p>
+        </p:txBody>
+      </p:sp>
+      <p:sp>
+        <p:nvSpPr>
+          <p:cNvPr id="22" name="TextBox 21"/>
+          <p:cNvSpPr txBox="1"/>
+          <p:nvPr/>
+        </p:nvSpPr>
+        <p:spPr>
+          <a:xfrm>
+            <a:off x="457200" y="3785616"/>
+            <a:ext cx="7498080" cy="347472"/>
+          </a:xfrm>
+          <a:prstGeom prst="rect">
+            <a:avLst/>
+          </a:prstGeom>
+          <a:noFill/>
+        </p:spPr>
+        <p:txBody>
+          <a:bodyPr wrap="square">
+            <a:spAutoFit/>
+          </a:bodyPr>
+          <a:lstStyle/>
+          <a:p>
+            <a:pPr algn="l"/>
+            <a:r>
+              <a:rPr sz="1100" b="1">
+                <a:solidFill>
+                  <a:srgbClr val="212121"/>
+                </a:solidFill>
+              </a:rPr>
+              <a:t>El Correo Ilustrado</a:t>
+            </a:r>
+          </a:p>
+        </p:txBody>
+      </p:sp>
+      <p:sp>
+        <p:nvSpPr>
+          <p:cNvPr id="23" name="TextBox 22"/>
+          <p:cNvSpPr txBox="1"/>
+          <p:nvPr/>
+        </p:nvSpPr>
+        <p:spPr>
+          <a:xfrm>
+            <a:off x="457200" y="4133088"/>
+            <a:ext cx="8321040" cy="502920"/>
+          </a:xfrm>
+          <a:prstGeom prst="rect">
+            <a:avLst/>
+          </a:prstGeom>
+          <a:noFill/>
+        </p:spPr>
+        <p:txBody>
+          <a:bodyPr wrap="square">
+            <a:spAutoFit/>
+          </a:bodyPr>
+          <a:lstStyle/>
+          <a:p>
+            <a:pPr algn="l"/>
+            <a:r>
+              <a:rPr sz="900" b="0">
+                <a:solidFill>
+                  <a:srgbClr val="757575"/>
+                </a:solidFill>
+              </a:rPr>
+              <a:t>Durante siglos, Occidente creyó que el centro del mundo le pertenecía. Pero mientras los imperios nacían y caían, China seguía allí: antigua, paciente, inmensa.…</a:t>
+            </a:r>
+          </a:p>
+        </p:txBody>
+      </p:sp>
+      <p:sp>
+        <p:nvSpPr>
+          <p:cNvPr id="24" name="TextBox 23"/>
+          <p:cNvSpPr txBox="1"/>
+          <p:nvPr/>
+        </p:nvSpPr>
+        <p:spPr>
+          <a:xfrm>
+            <a:off x="457200" y="4654296"/>
+            <a:ext cx="3657600" cy="228600"/>
+          </a:xfrm>
+          <a:prstGeom prst="rect">
+            <a:avLst/>
+          </a:prstGeom>
+          <a:noFill/>
+        </p:spPr>
+        <p:txBody>
+          <a:bodyPr wrap="square">
+            <a:spAutoFit/>
+          </a:bodyPr>
+          <a:lstStyle/>
+          <a:p>
+            <a:pPr algn="l"/>
+            <a:r>
+              <a:rPr sz="800" b="0">
+                <a:solidFill>
+                  <a:srgbClr val="757575"/>
+                </a:solidFill>
+              </a:rPr>
+              <a:t>📰 Jornada.com.mx</a:t>
+            </a:r>
+          </a:p>
+        </p:txBody>
+      </p:sp>
+      <p:sp>
+        <p:nvSpPr>
+          <p:cNvPr id="25" name="Rectangle 24"/>
+          <p:cNvSpPr/>
+          <p:nvPr/>
+        </p:nvSpPr>
+        <p:spPr>
+          <a:xfrm>
+            <a:off x="274320" y="5038344"/>
+            <a:ext cx="8595360" cy="1234440"/>
+          </a:xfrm>
+          <a:prstGeom prst="rect">
+            <a:avLst/>
+          </a:prstGeom>
+          <a:solidFill>
+            <a:srgbClr val="FFFFFF"/>
+          </a:solidFill>
+          <a:ln>
+            <a:noFill/>
+          </a:ln>
+        </p:spPr>
+        <p:style>
+          <a:lnRef idx="1">
+            <a:schemeClr val="accent1"/>
+          </a:lnRef>
+          <a:fillRef idx="3">
+            <a:schemeClr val="accent1"/>
+          </a:fillRef>
+          <a:effectRef idx="2">
+            <a:schemeClr val="accent1"/>
+          </a:effectRef>
+          <a:fontRef idx="minor">
+            <a:schemeClr val="lt1"/>
+          </a:fontRef>
+        </p:style>
+        <p:txBody>
+          <a:bodyPr rtlCol="0" anchor="ctr"/>
+          <a:lstStyle/>
+          <a:p>
+            <a:pPr algn="ctr"/>
+          </a:p>
+        </p:txBody>
+      </p:sp>
+      <p:sp>
+        <p:nvSpPr>
+          <p:cNvPr id="26" name="Rectangle 25"/>
+          <p:cNvSpPr/>
+          <p:nvPr/>
+        </p:nvSpPr>
+        <p:spPr>
+          <a:xfrm>
+            <a:off x="274320" y="5038344"/>
+            <a:ext cx="54864" cy="1234440"/>
           </a:xfrm>
           <a:prstGeom prst="rect">
             <a:avLst/>
@@ -7555,193 +7777,14 @@
       </p:sp>
       <p:sp>
         <p:nvSpPr>
-          <p:cNvPr id="21" name="TextBox 20"/>
-          <p:cNvSpPr txBox="1"/>
-          <p:nvPr/>
-        </p:nvSpPr>
-        <p:spPr>
-          <a:xfrm>
-            <a:off x="8138160" y="3785616"/>
+          <p:cNvPr id="27" name="Rectangle 26"/>
+          <p:cNvSpPr/>
+          <p:nvPr/>
+        </p:nvSpPr>
+        <p:spPr>
+          <a:xfrm>
+            <a:off x="8138160" y="5129784"/>
             <a:ext cx="640080" cy="274320"/>
-          </a:xfrm>
-          <a:prstGeom prst="rect">
-            <a:avLst/>
-          </a:prstGeom>
-          <a:noFill/>
-        </p:spPr>
-        <p:txBody>
-          <a:bodyPr wrap="square">
-            <a:spAutoFit/>
-          </a:bodyPr>
-          <a:lstStyle/>
-          <a:p>
-            <a:pPr algn="ctr"/>
-            <a:r>
-              <a:rPr sz="900" b="1">
-                <a:solidFill>
-                  <a:srgbClr val="FFFFFF"/>
-                </a:solidFill>
-              </a:rPr>
-              <a:t>5/10</a:t>
-            </a:r>
-          </a:p>
-        </p:txBody>
-      </p:sp>
-      <p:sp>
-        <p:nvSpPr>
-          <p:cNvPr id="22" name="TextBox 21"/>
-          <p:cNvSpPr txBox="1"/>
-          <p:nvPr/>
-        </p:nvSpPr>
-        <p:spPr>
-          <a:xfrm>
-            <a:off x="457200" y="3785616"/>
-            <a:ext cx="7498080" cy="347472"/>
-          </a:xfrm>
-          <a:prstGeom prst="rect">
-            <a:avLst/>
-          </a:prstGeom>
-          <a:noFill/>
-        </p:spPr>
-        <p:txBody>
-          <a:bodyPr wrap="square">
-            <a:spAutoFit/>
-          </a:bodyPr>
-          <a:lstStyle/>
-          <a:p>
-            <a:pPr algn="l"/>
-            <a:r>
-              <a:rPr sz="1100" b="1">
-                <a:solidFill>
-                  <a:srgbClr val="212121"/>
-                </a:solidFill>
-              </a:rPr>
-              <a:t>La Plataforma Bienvenidos refugiados de La Rioja realiza una recogida de ropa y enseres pa…</a:t>
-            </a:r>
-          </a:p>
-        </p:txBody>
-      </p:sp>
-      <p:sp>
-        <p:nvSpPr>
-          <p:cNvPr id="23" name="TextBox 22"/>
-          <p:cNvSpPr txBox="1"/>
-          <p:nvPr/>
-        </p:nvSpPr>
-        <p:spPr>
-          <a:xfrm>
-            <a:off x="457200" y="4133088"/>
-            <a:ext cx="8321040" cy="502920"/>
-          </a:xfrm>
-          <a:prstGeom prst="rect">
-            <a:avLst/>
-          </a:prstGeom>
-          <a:noFill/>
-        </p:spPr>
-        <p:txBody>
-          <a:bodyPr wrap="square">
-            <a:spAutoFit/>
-          </a:bodyPr>
-          <a:lstStyle/>
-          <a:p>
-            <a:pPr algn="l"/>
-            <a:r>
-              <a:rPr sz="900" b="0">
-                <a:solidFill>
-                  <a:srgbClr val="757575"/>
-                </a:solidFill>
-              </a:rPr>
-              <a:t>La Plataforma Bienvenidos refugiados de La Rioja vuelve, un año más, a gestionar una recogida solidaria de ropa y enseres, los días 22, 23 y 24 de mayo. La Plat…</a:t>
-            </a:r>
-          </a:p>
-        </p:txBody>
-      </p:sp>
-      <p:sp>
-        <p:nvSpPr>
-          <p:cNvPr id="24" name="TextBox 23"/>
-          <p:cNvSpPr txBox="1"/>
-          <p:nvPr/>
-        </p:nvSpPr>
-        <p:spPr>
-          <a:xfrm>
-            <a:off x="457200" y="4654296"/>
-            <a:ext cx="3657600" cy="228600"/>
-          </a:xfrm>
-          <a:prstGeom prst="rect">
-            <a:avLst/>
-          </a:prstGeom>
-          <a:noFill/>
-        </p:spPr>
-        <p:txBody>
-          <a:bodyPr wrap="square">
-            <a:spAutoFit/>
-          </a:bodyPr>
-          <a:lstStyle/>
-          <a:p>
-            <a:pPr algn="l"/>
-            <a:r>
-              <a:rPr sz="800" b="0">
-                <a:solidFill>
-                  <a:srgbClr val="757575"/>
-                </a:solidFill>
-              </a:rPr>
-              <a:t>📰 Europapress.es</a:t>
-            </a:r>
-          </a:p>
-        </p:txBody>
-      </p:sp>
-      <p:sp>
-        <p:nvSpPr>
-          <p:cNvPr id="25" name="Rectangle 24"/>
-          <p:cNvSpPr/>
-          <p:nvPr/>
-        </p:nvSpPr>
-        <p:spPr>
-          <a:xfrm>
-            <a:off x="274320" y="5038344"/>
-            <a:ext cx="8595360" cy="1234440"/>
-          </a:xfrm>
-          <a:prstGeom prst="rect">
-            <a:avLst/>
-          </a:prstGeom>
-          <a:solidFill>
-            <a:srgbClr val="FFFFFF"/>
-          </a:solidFill>
-          <a:ln>
-            <a:noFill/>
-          </a:ln>
-        </p:spPr>
-        <p:style>
-          <a:lnRef idx="1">
-            <a:schemeClr val="accent1"/>
-          </a:lnRef>
-          <a:fillRef idx="3">
-            <a:schemeClr val="accent1"/>
-          </a:fillRef>
-          <a:effectRef idx="2">
-            <a:schemeClr val="accent1"/>
-          </a:effectRef>
-          <a:fontRef idx="minor">
-            <a:schemeClr val="lt1"/>
-          </a:fontRef>
-        </p:style>
-        <p:txBody>
-          <a:bodyPr rtlCol="0" anchor="ctr"/>
-          <a:lstStyle/>
-          <a:p>
-            <a:pPr algn="ctr"/>
-          </a:p>
-        </p:txBody>
-      </p:sp>
-      <p:sp>
-        <p:nvSpPr>
-          <p:cNvPr id="26" name="Rectangle 25"/>
-          <p:cNvSpPr/>
-          <p:nvPr/>
-        </p:nvSpPr>
-        <p:spPr>
-          <a:xfrm>
-            <a:off x="274320" y="5038344"/>
-            <a:ext cx="54864" cy="1234440"/>
           </a:xfrm>
           <a:prstGeom prst="rect">
             <a:avLst/>
@@ -7777,49 +7820,6 @@
       </p:sp>
       <p:sp>
         <p:nvSpPr>
-          <p:cNvPr id="27" name="Rectangle 26"/>
-          <p:cNvSpPr/>
-          <p:nvPr/>
-        </p:nvSpPr>
-        <p:spPr>
-          <a:xfrm>
-            <a:off x="8138160" y="5129784"/>
-            <a:ext cx="640080" cy="274320"/>
-          </a:xfrm>
-          <a:prstGeom prst="rect">
-            <a:avLst/>
-          </a:prstGeom>
-          <a:solidFill>
-            <a:srgbClr val="2E7D32"/>
-          </a:solidFill>
-          <a:ln>
-            <a:noFill/>
-          </a:ln>
-        </p:spPr>
-        <p:style>
-          <a:lnRef idx="1">
-            <a:schemeClr val="accent1"/>
-          </a:lnRef>
-          <a:fillRef idx="3">
-            <a:schemeClr val="accent1"/>
-          </a:fillRef>
-          <a:effectRef idx="2">
-            <a:schemeClr val="accent1"/>
-          </a:effectRef>
-          <a:fontRef idx="minor">
-            <a:schemeClr val="lt1"/>
-          </a:fontRef>
-        </p:style>
-        <p:txBody>
-          <a:bodyPr rtlCol="0" anchor="ctr"/>
-          <a:lstStyle/>
-          <a:p>
-            <a:pPr algn="ctr"/>
-          </a:p>
-        </p:txBody>
-      </p:sp>
-      <p:sp>
-        <p:nvSpPr>
           <p:cNvPr id="28" name="TextBox 27"/>
           <p:cNvSpPr txBox="1"/>
           <p:nvPr/>
@@ -7881,7 +7881,7 @@
                   <a:srgbClr val="212121"/>
                 </a:solidFill>
               </a:rPr>
-              <a:t>Alumnos de Murcia celebran el Día de la Diversidad Cultural con una conexión en directo co…</a:t>
+              <a:t>El Sindicato de Inquilinas se encierra en la sede de la Seguridad Social hasta que el Gobi…</a:t>
             </a:r>
           </a:p>
         </p:txBody>
@@ -7915,7 +7915,7 @@
                   <a:srgbClr val="757575"/>
                 </a:solidFill>
               </a:rPr>
-              <a:t>Promover el respeto, la convivencia y el entendimiento entre culturas desde las edades más tempranas. Ese es el objetivo con el que El Limonar International Sch…</a:t>
+              <a:t/>
             </a:r>
           </a:p>
         </p:txBody>
@@ -7949,7 +7949,7 @@
                   <a:srgbClr val="757575"/>
                 </a:solidFill>
               </a:rPr>
-              <a:t>📰 Www.abc.es</a:t>
+              <a:t>📰 Huffingtonpost.es</a:t>
             </a:r>
           </a:p>
         </p:txBody>

</xml_diff>